<commit_message>
Updates to System Design
</commit_message>
<xml_diff>
--- a/MongoDB.pptx
+++ b/MongoDB.pptx
@@ -274,7 +274,7 @@
           <a:p>
             <a:fld id="{B66E714E-885D-4D12-977C-C047A2AC8E1D}" type="datetimeFigureOut">
               <a:rPr lang="en-IN" smtClean="0"/>
-              <a:t>20-11-2023</a:t>
+              <a:t>27-01-2025</a:t>
             </a:fld>
             <a:endParaRPr lang="en-IN"/>
           </a:p>
@@ -474,7 +474,7 @@
           <a:p>
             <a:fld id="{B66E714E-885D-4D12-977C-C047A2AC8E1D}" type="datetimeFigureOut">
               <a:rPr lang="en-IN" smtClean="0"/>
-              <a:t>20-11-2023</a:t>
+              <a:t>27-01-2025</a:t>
             </a:fld>
             <a:endParaRPr lang="en-IN"/>
           </a:p>
@@ -684,7 +684,7 @@
           <a:p>
             <a:fld id="{B66E714E-885D-4D12-977C-C047A2AC8E1D}" type="datetimeFigureOut">
               <a:rPr lang="en-IN" smtClean="0"/>
-              <a:t>20-11-2023</a:t>
+              <a:t>27-01-2025</a:t>
             </a:fld>
             <a:endParaRPr lang="en-IN"/>
           </a:p>
@@ -965,7 +965,7 @@
           <a:p>
             <a:fld id="{B66E714E-885D-4D12-977C-C047A2AC8E1D}" type="datetimeFigureOut">
               <a:rPr lang="en-IN" smtClean="0"/>
-              <a:t>20-11-2023</a:t>
+              <a:t>27-01-2025</a:t>
             </a:fld>
             <a:endParaRPr lang="en-IN"/>
           </a:p>
@@ -1241,7 +1241,7 @@
           <a:p>
             <a:fld id="{B66E714E-885D-4D12-977C-C047A2AC8E1D}" type="datetimeFigureOut">
               <a:rPr lang="en-IN" smtClean="0"/>
-              <a:t>20-11-2023</a:t>
+              <a:t>27-01-2025</a:t>
             </a:fld>
             <a:endParaRPr lang="en-IN"/>
           </a:p>
@@ -1509,7 +1509,7 @@
           <a:p>
             <a:fld id="{B66E714E-885D-4D12-977C-C047A2AC8E1D}" type="datetimeFigureOut">
               <a:rPr lang="en-IN" smtClean="0"/>
-              <a:t>20-11-2023</a:t>
+              <a:t>27-01-2025</a:t>
             </a:fld>
             <a:endParaRPr lang="en-IN"/>
           </a:p>
@@ -1924,7 +1924,7 @@
           <a:p>
             <a:fld id="{B66E714E-885D-4D12-977C-C047A2AC8E1D}" type="datetimeFigureOut">
               <a:rPr lang="en-IN" smtClean="0"/>
-              <a:t>20-11-2023</a:t>
+              <a:t>27-01-2025</a:t>
             </a:fld>
             <a:endParaRPr lang="en-IN"/>
           </a:p>
@@ -2066,7 +2066,7 @@
           <a:p>
             <a:fld id="{B66E714E-885D-4D12-977C-C047A2AC8E1D}" type="datetimeFigureOut">
               <a:rPr lang="en-IN" smtClean="0"/>
-              <a:t>20-11-2023</a:t>
+              <a:t>27-01-2025</a:t>
             </a:fld>
             <a:endParaRPr lang="en-IN"/>
           </a:p>
@@ -2179,7 +2179,7 @@
           <a:p>
             <a:fld id="{B66E714E-885D-4D12-977C-C047A2AC8E1D}" type="datetimeFigureOut">
               <a:rPr lang="en-IN" smtClean="0"/>
-              <a:t>20-11-2023</a:t>
+              <a:t>27-01-2025</a:t>
             </a:fld>
             <a:endParaRPr lang="en-IN"/>
           </a:p>
@@ -2492,7 +2492,7 @@
           <a:p>
             <a:fld id="{B66E714E-885D-4D12-977C-C047A2AC8E1D}" type="datetimeFigureOut">
               <a:rPr lang="en-IN" smtClean="0"/>
-              <a:t>20-11-2023</a:t>
+              <a:t>27-01-2025</a:t>
             </a:fld>
             <a:endParaRPr lang="en-IN"/>
           </a:p>
@@ -2781,7 +2781,7 @@
           <a:p>
             <a:fld id="{B66E714E-885D-4D12-977C-C047A2AC8E1D}" type="datetimeFigureOut">
               <a:rPr lang="en-IN" smtClean="0"/>
-              <a:t>20-11-2023</a:t>
+              <a:t>27-01-2025</a:t>
             </a:fld>
             <a:endParaRPr lang="en-IN"/>
           </a:p>
@@ -3024,7 +3024,7 @@
           <a:p>
             <a:fld id="{B66E714E-885D-4D12-977C-C047A2AC8E1D}" type="datetimeFigureOut">
               <a:rPr lang="en-IN" smtClean="0"/>
-              <a:t>20-11-2023</a:t>
+              <a:t>27-01-2025</a:t>
             </a:fld>
             <a:endParaRPr lang="en-IN"/>
           </a:p>
@@ -13742,7 +13742,7 @@
         <p:spPr>
           <a:xfrm>
             <a:off x="647487" y="1315348"/>
-            <a:ext cx="4425255" cy="4893647"/>
+            <a:ext cx="4425255" cy="4659417"/>
           </a:xfrm>
           <a:prstGeom prst="rect">
             <a:avLst/>
@@ -13769,106 +13769,106 @@
           </a:p>
           <a:p>
             <a:pPr algn="l">
+              <a:lnSpc>
+                <a:spcPts val="2400"/>
+              </a:lnSpc>
+              <a:spcAft>
+                <a:spcPts val="1290"/>
+              </a:spcAft>
               <a:buFont typeface="Arial" panose="020B0604020202020204" pitchFamily="34" charset="0"/>
               <a:buChar char="•"/>
             </a:pPr>
             <a:r>
               <a:rPr lang="en-US" sz="2400" b="1" i="0" dirty="0">
-                <a:solidFill>
-                  <a:srgbClr val="090B0B"/>
-                </a:solidFill>
                 <a:effectLst/>
-                <a:latin typeface="Inter"/>
+                <a:latin typeface="__Source_Sans_3_a605e5"/>
               </a:rPr>
               <a:t>Atomicity</a:t>
             </a:r>
             <a:r>
               <a:rPr lang="en-US" sz="2400" b="0" i="0" dirty="0">
-                <a:solidFill>
-                  <a:srgbClr val="090B0B"/>
-                </a:solidFill>
                 <a:effectLst/>
-                <a:latin typeface="Inter"/>
+                <a:latin typeface="__Source_Sans_3_a605e5"/>
               </a:rPr>
-              <a:t> - Transactions are treated as a single unit - so if one action fails, the whole transaction fails.</a:t>
+              <a:t>: Ensures that a transaction is either fully completed or not executed at all.</a:t>
             </a:r>
           </a:p>
           <a:p>
             <a:pPr algn="l">
+              <a:lnSpc>
+                <a:spcPts val="2400"/>
+              </a:lnSpc>
+              <a:spcAft>
+                <a:spcPts val="1290"/>
+              </a:spcAft>
               <a:buFont typeface="Arial" panose="020B0604020202020204" pitchFamily="34" charset="0"/>
               <a:buChar char="•"/>
             </a:pPr>
             <a:r>
               <a:rPr lang="en-US" sz="2400" b="1" i="0" dirty="0">
-                <a:solidFill>
-                  <a:srgbClr val="090B0B"/>
-                </a:solidFill>
                 <a:effectLst/>
-                <a:latin typeface="Inter"/>
+                <a:latin typeface="__Source_Sans_3_a605e5"/>
               </a:rPr>
               <a:t>Consistency</a:t>
             </a:r>
             <a:r>
               <a:rPr lang="en-US" sz="2400" b="0" i="0" dirty="0">
-                <a:solidFill>
-                  <a:srgbClr val="090B0B"/>
-                </a:solidFill>
                 <a:effectLst/>
-                <a:latin typeface="Inter"/>
+                <a:latin typeface="__Source_Sans_3_a605e5"/>
               </a:rPr>
-              <a:t> - The database must remain in a consistent state for a transaction to succeed.</a:t>
+              <a:t>: Guarantees that a transaction brings the database from one valid state to another.</a:t>
             </a:r>
           </a:p>
           <a:p>
             <a:pPr algn="l">
+              <a:lnSpc>
+                <a:spcPts val="2400"/>
+              </a:lnSpc>
+              <a:spcAft>
+                <a:spcPts val="1290"/>
+              </a:spcAft>
               <a:buFont typeface="Arial" panose="020B0604020202020204" pitchFamily="34" charset="0"/>
               <a:buChar char="•"/>
             </a:pPr>
             <a:r>
               <a:rPr lang="en-US" sz="2400" b="1" i="0" dirty="0">
-                <a:solidFill>
-                  <a:srgbClr val="090B0B"/>
-                </a:solidFill>
                 <a:effectLst/>
-                <a:latin typeface="Inter"/>
+                <a:latin typeface="__Source_Sans_3_a605e5"/>
               </a:rPr>
               <a:t>Isolation</a:t>
             </a:r>
             <a:r>
               <a:rPr lang="en-US" sz="2400" b="0" i="0" dirty="0">
-                <a:solidFill>
-                  <a:srgbClr val="090B0B"/>
-                </a:solidFill>
                 <a:effectLst/>
-                <a:latin typeface="Inter"/>
+                <a:latin typeface="__Source_Sans_3_a605e5"/>
               </a:rPr>
-              <a:t> - Simultaneous transactions do not affect the outcome of one another.</a:t>
+              <a:t>: Ensures that concurrent transactions do not interfere with each other.</a:t>
             </a:r>
           </a:p>
           <a:p>
             <a:pPr algn="l">
+              <a:lnSpc>
+                <a:spcPts val="2400"/>
+              </a:lnSpc>
+              <a:spcAft>
+                <a:spcPts val="1290"/>
+              </a:spcAft>
               <a:buFont typeface="Arial" panose="020B0604020202020204" pitchFamily="34" charset="0"/>
               <a:buChar char="•"/>
             </a:pPr>
             <a:r>
-              <a:rPr lang="en-US" sz="2400" b="1" i="0" dirty="0">
-                <a:solidFill>
-                  <a:srgbClr val="090B0B"/>
-                </a:solidFill>
+              <a:rPr lang="en-US" sz="2400" b="1" i="0">
                 <a:effectLst/>
-                <a:latin typeface="Inter"/>
+                <a:latin typeface="__Source_Sans_3_a605e5"/>
               </a:rPr>
               <a:t>Durability</a:t>
             </a:r>
             <a:r>
-              <a:rPr lang="en-US" sz="2400" b="0" i="0" dirty="0">
-                <a:solidFill>
-                  <a:srgbClr val="090B0B"/>
-                </a:solidFill>
+              <a:rPr lang="en-US" sz="2400" b="0" i="0">
                 <a:effectLst/>
-                <a:latin typeface="Inter"/>
+                <a:latin typeface="__Source_Sans_3_a605e5"/>
               </a:rPr>
-              <a:t> - Successful changes will be stored permanently.</a:t>
+              <a:t>: Once a transaction is committed, it remains so, even in the event of a system failure.</a:t>
             </a:r>
           </a:p>
         </p:txBody>

</xml_diff>